<commit_message>
Add AI and fixes
</commit_message>
<xml_diff>
--- a/RecurrSave.pptx
+++ b/RecurrSave.pptx
@@ -293,7 +293,7 @@
                 </a:solidFill>
                 <a:latin typeface="Arial"/>
               </a:rPr>
-              <a:t>Plan your budget. Build your savings.</a:t>
+              <a:t>Gmail API + Engine Spaces</a:t>
             </a:r>
             <a:endParaRPr lang="en-GB" sz="1800"/>
           </a:p>
@@ -413,7 +413,7 @@
                 </a:solidFill>
                 <a:latin typeface="Arial"/>
               </a:rPr>
-              <a:t>Concept demo · Gmail, transfers and interest boosts are simulated</a:t>
+              <a:t>Prototype · Gmail API, Engine Spaces and interest boosts are simulated</a:t>
             </a:r>
             <a:endParaRPr lang="en-GB" sz="1000"/>
           </a:p>
@@ -616,7 +616,7 @@
                 </a:solidFill>
                 <a:latin typeface="Arial"/>
               </a:rPr>
-              <a:t>Set your budget. Choose a rule. Watch your goal grow.</a:t>
+              <a:t>Gmail API → savings rules → Engine Spaces</a:t>
             </a:r>
             <a:endParaRPr lang="en-GB" sz="2200"/>
           </a:p>
@@ -675,7 +675,7 @@
                 </a:solidFill>
                 <a:latin typeface="Arial"/>
               </a:rPr>
-              <a:t>01  RECEIPT</a:t>
+              <a:t>01  GMAIL API</a:t>
             </a:r>
             <a:endParaRPr lang="en-GB" sz="1300"/>
           </a:p>
@@ -749,7 +749,7 @@
                 </a:solidFill>
                 <a:latin typeface="Arial"/>
               </a:rPr>
-              <a:t>Simulated gym purchase</a:t>
+              <a:t>Gym receipt (simulated)</a:t>
             </a:r>
             <a:endParaRPr lang="en-GB" sz="1500"/>
           </a:p>
@@ -1015,7 +1015,7 @@
                 </a:solidFill>
                 <a:latin typeface="Arial"/>
               </a:rPr>
-              <a:t>03  GOAL SPACE</a:t>
+              <a:t>03  ENGINE SPACES</a:t>
             </a:r>
             <a:endParaRPr lang="en-GB" sz="1300"/>
           </a:p>
@@ -1089,7 +1089,7 @@
                 </a:solidFill>
                 <a:latin typeface="Arial"/>
               </a:rPr>
-              <a:t>Saved towards your goal</a:t>
+              <a:t>Goal saving (simulated)</a:t>
             </a:r>
             <a:endParaRPr lang="en-GB" sz="1500"/>
           </a:p>
@@ -1163,7 +1163,7 @@
                 </a:solidFill>
                 <a:latin typeface="Arial"/>
               </a:rPr>
-              <a:t>Concept demo · Gmail, transfers and interest boosts are simulated</a:t>
+              <a:t>Prototype · Gmail API, Engine Spaces and interest boosts are simulated</a:t>
             </a:r>
             <a:endParaRPr lang="en-GB" sz="1000"/>
           </a:p>
@@ -1634,7 +1634,7 @@
                 </a:solidFill>
                 <a:latin typeface="Arial"/>
               </a:rPr>
-              <a:t>Concept demo · Gmail, transfers and interest boosts are simulated</a:t>
+              <a:t>Prototype · Gmail API, Engine Spaces and interest boosts are simulated</a:t>
             </a:r>
             <a:endParaRPr lang="en-GB" sz="1000"/>
           </a:p>

</xml_diff>